<commit_message>
docs: presentación actualizada con la limitación de Jira en producción
Co-Authored-By: Claude Opus 5.5 <noreply@anthropic.com>
</commit_message>
<xml_diff>
--- a/docs/wiki-viva-presentacion.pptx
+++ b/docs/wiki-viva-presentacion.pptx
@@ -602,7 +602,7 @@
           <a:p>
             <a:r>
               <a:rPr lang="en-US" dirty="0"/>
-              <a:t>Los modelos gratis fueron el mayor desafío: saturados, con cupo diario y comportamientos raros, como responder en el canal de razonamiento o entrar en loop. Cada problema dejó una mejora concreta en el código. El aprendizaje de fondo: con IA, el humano en el loop no es opcional, la extracción sola produce ruido y la revisión es lo que da calidad.</a:t>
+              <a:t>Los modelos gratis fueron el mayor desafío: saturados, con cupo diario y comportamientos raros, como responder en el canal de razonamiento o entrar en loop. Cada problema dejó una mejora concreta en el código. El aprendizaje de fondo: con IA, el humano en el loop no es opcional, la extracción sola produce ruido y la revisión es lo que da calidad. El último desafío apareció en producción: el Jira del cliente solo acepta conexiones por VPN o desde IPs permitidas, y Vercel no está en esa lista. El chat siguió funcionando con el glosario porque está diseñado para tolerar la caída de Jira, pero sin el detalle de las tarjetas.</a:t>
             </a:r>
             <a:endParaRPr lang="en-US" dirty="0"/>
           </a:p>
@@ -690,7 +690,7 @@
           <a:p>
             <a:r>
               <a:rPr lang="en-US" dirty="0"/>
-              <a:t>El MVP está en producción y el repo público entregado. Queda pendiente probar de punta a punta el guardado de un término nuevo desde el chat y la fase de validación: correr 15 a 20 preguntas reales y ajustar las respuestas, que hoy son correctas pero cortas.</a:t>
+              <a:t>El MVP está en producción y el repo público entregado. Una salvedad: en producción el chat no puede leer el Jira del cliente (solo acepta VPN), así que responde con el glosario; en local, con VPN, funciona completo. Queda pendiente probar de punta a punta el guardado de un término nuevo desde el chat y la fase de validación: correr 15 a 20 preguntas reales y ajustar las respuestas, que hoy son correctas pero cortas.</a:t>
             </a:r>
             <a:endParaRPr lang="en-US" dirty="0"/>
           </a:p>
@@ -778,7 +778,7 @@
           <a:p>
             <a:r>
               <a:rPr lang="en-US" dirty="0"/>
-              <a:t>Las cuatro mejoras están detalladas en el PLAN.md del repo. La de mayor impacto inmediato es la calidad de las respuestas: con un modelo gratis y 120 mil tokens de contexto, el chat copia en lugar de redactar. Las otras tres apuntan a escalar: identidad real, más épicas y permisos por equipo.</a:t>
+              <a:t>Las cinco mejoras están detalladas en el PLAN.md del repo, en orden de prioridad. La primera es que el chat de producción vuelva a tener las tarjetas: como el Jira del cliente solo acepta VPN, la idea es generar el snapshot de la épica desde una red con acceso (o desde Claude con el MCP de Atlassian, si pasa la lista de IPs) y publicarlo en el repo privado, igual que el glosario. Después, la calidad de las respuestas: con un modelo gratis y 120 mil tokens de contexto, el chat copia en lugar de redactar. Las otras tres apuntan a escalar: identidad real, más épicas y permisos por equipo.</a:t>
             </a:r>
             <a:endParaRPr lang="en-US" dirty="0"/>
           </a:p>
@@ -1482,7 +1482,7 @@
           <a:p>
             <a:r>
               <a:rPr lang="en-US" dirty="0"/>
-              <a:t>Guion sugerido. 1: en la wiki, buscar "hecho generador" o una sigla como "Mt. a Pagar": el buscador encuentra también por sinónimos. 2: en el chat, "¿Qué pasa con las autorizaciones cuando se genera el compromiso?": respuesta con citas, pasar el mouse sobre una clave para ver el título y mostrar la lista de Fuentes. 3: preguntar por un término que no esté, por ejemplo "reaseguro facultativo": aparece "No lo sé" y el botón Agregar al glosario. Ojo: el guardado real del formulario todavía no se probó de punta a punta; mostrar el formulario sin guardar, o probarlo antes. Con modelos gratis el chat puede tardar o estar saturado: tener capturas de respaldo.</a:t>
+              <a:t>Guion sugerido. 1: en la wiki, buscar "hecho generador" o una sigla como "Mt. a Pagar": el buscador encuentra también por sinónimos. 2: en el chat, "¿Qué pasa con las autorizaciones cuando se genera el compromiso?": respuesta con citas. Importante: el Jira del cliente solo acepta VPN, así que en producción el chat responde solo con el glosario y sin títulos en las citas. Para mostrar los títulos al pasar el mouse y la lista de Fuentes, hacer la demo en local con la VPN conectada. 3: preguntar por un término que no esté, por ejemplo "reaseguro facultativo": aparece "No lo sé" y el botón Agregar al glosario. Ojo: el guardado real del formulario todavía no se probó de punta a punta; mostrar el formulario sin guardar, o probarlo antes. Con modelos gratis el chat puede tardar o estar saturado: tener capturas de respaldo.</a:t>
             </a:r>
             <a:endParaRPr lang="en-US" dirty="0"/>
           </a:p>
@@ -1987,7 +1987,7 @@
       </p:grpSpPr>
       <p:pic>
         <p:nvPicPr>
-          <p:cNvPr id="2" name="Slide 10" descr="Flock | Aprendizajes 10 Lo que aprendimos en el camino Desafío Qué hicimos Modelos gratis saturados (error 429) Lista de modelos de respaldo en una variable Cupo de 50 pedidos por día Caché por lote: la extracción retoma sin repetir Extracción trabada más de 10 minutos Lotes chicos, tiempo máximo y log por intento Respuestas en el canal de &quot;razonamiento&quot; Razonamiento apagado en el chat 394 términos con duplicados Fusión automática más revisión humana El glosario quedaba en el historial de git Repo nuevo con historial limpio y datos aparte">    </p:cNvPr>
+          <p:cNvPr id="2" name="Slide 10" descr="Flock | Aprendizajes 10 Lo que aprendimos en el camino Desafío Qué hicimos Modelos gratis saturados (error 429) Lista de modelos de respaldo en una variable Cupo de 50 pedidos por día Caché por lote: la extracción retoma sin repetir Extracción trabada más de 10 minutos Lotes chicos, tiempo máximo y log por intento Respuestas en el canal de &quot;razonamiento&quot; Razonamiento apagado en el chat 394 términos con duplicados Fusión automática más revisión humana El glosario quedaba en el historial de git Repo nuevo con historial limpio y datos aparte Jira del cliente solo por VPN o IPs permitidas En producción el chat usa solo el glosario; próximo paso: publicar el snapshot de la épica">    </p:cNvPr>
           <p:cNvPicPr>
             <a:picLocks noChangeAspect="1"/>
           </p:cNvPicPr>
@@ -2036,7 +2036,7 @@
       </p:grpSpPr>
       <p:pic>
         <p:nvPicPr>
-          <p:cNvPr id="2" name="Slide 11" descr="Flock | Aprendizajes 11 Dónde estamos Fase Estado 0–1 · Base del proyecto y conector de Jira Completa 2–3 · Extracción y revisión humana Completa 4–5 · Wiki y chat con streaming Completa 6 · Citas y &quot;Agregar al glosario&quot; Implementada, falta prueba con guardado real 7 · Validación de respuestas Pendiente 8 · Deploy final y entrega Completa">    </p:cNvPr>
+          <p:cNvPr id="2" name="Slide 11" descr="Flock | Aprendizajes 11 Dónde estamos Fase Estado 0–1 · Base del proyecto y conector de Jira Completa 2–3 · Extracción y revisión humana Completa 4–5 · Wiki y chat con streaming Completa; en producción, el chat sin acceso a Jira 6 · Citas y &quot;Agregar al glosario&quot; Implementada, falta prueba con guardado real 7 · Validación de respuestas Pendiente 8 · Deploy final y entrega Completa">    </p:cNvPr>
           <p:cNvPicPr>
             <a:picLocks noChangeAspect="1"/>
           </p:cNvPicPr>
@@ -2085,7 +2085,7 @@
       </p:grpSpPr>
       <p:pic>
         <p:nvPicPr>
-          <p:cNvPr id="2" name="Slide 12" descr="Flock | Próximos pasos 12 Próximos pasos Mejores respuestas Un modelo más capaz y solo las tarjetas relevantes en el contexto, en lugar de toda la épica. Login con Microsoft 365 Sin contraseñas compartidas, y queda registrado quién agrega cada término. Varias épicas Extracción incremental que suma una épica nueva al glosario, con filtro por épica en la wiki. Acceso por equipo Cada persona ve solo las épicas de su equipo, según sus grupos de Microsoft 365.">    </p:cNvPr>
+          <p:cNvPr id="2" name="Slide 12" descr="Flock | Próximos pasos 12 Próximos pasos Jira en producción Publicar el snapshot de la épica en el repo privado, generado con VPN o con el MCP de Atlassian. Mejores respuestas Un modelo más capaz y solo las tarjetas relevantes en el contexto. Login con Microsoft 365 Sin contraseñas compartidas, y queda registrado quién agrega cada término. Varias épicas Extracción incremental y filtro por épica en la wiki. Acceso por equipo Cada persona ve solo las épicas de su equipo, según sus grupos de Microsoft 365.">    </p:cNvPr>
           <p:cNvPicPr>
             <a:picLocks noChangeAspect="1"/>
           </p:cNvPicPr>
@@ -2477,7 +2477,7 @@
       </p:grpSpPr>
       <p:pic>
         <p:nvPicPr>
-          <p:cNvPr id="2" name="Slide 8" descr="Flock | Resultados 08 Demo 1 Wiki: buscar un término o una sigla y ver definición, sinónimos, casos especiales y fuentes en Jira. 2 Chat: preguntar por una regla del negocio y ver la respuesta con citas, links y el título de cada tarjeta. 3 Sin datos: preguntar por un término que no existe. El chat dice &quot;No lo sé&quot; y ofrece agregarlo al glosario. wiki-viva.vercel.app · acceso con usuario y contraseña">    </p:cNvPr>
+          <p:cNvPr id="2" name="Slide 8" descr="Flock | Resultados 08 Demo 1 Wiki: buscar un término o una sigla y ver definición, sinónimos, casos especiales y fuentes en Jira. 2 Chat: preguntar por una regla del negocio y ver la respuesta con citas y links a Jira (títulos de las tarjetas: en local, con VPN). 3 Sin datos: preguntar por un término que no existe. El chat dice &quot;No lo sé&quot; y ofrece agregarlo al glosario. wiki-viva.vercel.app · acceso con usuario y contraseña">    </p:cNvPr>
           <p:cNvPicPr>
             <a:picLocks noChangeAspect="1"/>
           </p:cNvPicPr>

</xml_diff>

<commit_message>
docs: presentación con la arquitectura del MCP local
Portada y slides 03, 04, 05, 06 y 12 rehechas con el flujo del MCP,
la wiki de solo lectura por épica y los próximos pasos nuevos, con
sus notas y texto alternativo. Las slides 07 a 11 quedan como
historia del challenge.

Co-Authored-By: Claude Opus 5.5 <noreply@anthropic.com>
</commit_message>
<xml_diff>
--- a/docs/wiki-viva-presentacion.pptx
+++ b/docs/wiki-viva-presentacion.pptx
@@ -514,7 +514,7 @@
           <a:p>
             <a:r>
               <a:rPr lang="en-US" dirty="0"/>
-              <a:t>Presentación del challenge del IA Day. La idea: dejar de depender de un compañero cada vez que aparece un término del negocio que no conocemos. En los próximos minutos: el problema, qué construimos, cómo está hecho, qué resultados dio y qué sigue.</a:t>
+              <a:t>Presentación del challenge del IA Day, actualizada con la arquitectura actual. La idea: dejar de depender de un compañero cada vez que aparece un término del negocio que no conocemos. En los próximos minutos: el problema, qué construimos, cómo está hecho, qué resultados dio y qué sigue.</a:t>
             </a:r>
             <a:endParaRPr lang="en-US" dirty="0"/>
           </a:p>
@@ -778,7 +778,7 @@
           <a:p>
             <a:r>
               <a:rPr lang="en-US" dirty="0"/>
-              <a:t>Las cinco mejoras están detalladas en el PLAN.md del repo, en orden de prioridad. La primera es que el chat de producción vuelva a tener las tarjetas: como el Jira del cliente solo acepta VPN, la idea es generar el snapshot de la épica desde una red con acceso (o desde Claude con el MCP de Atlassian, si pasa la lista de IPs) y publicarlo en el repo privado, igual que el glosario. Después, la calidad de las respuestas: con un modelo gratis y 120 mil tokens de contexto, el chat copia en lugar de redactar. Las otras tres apuntan a escalar: identidad real, más épicas y permisos por equipo.</a:t>
+              <a:t>Las mejoras están detalladas en el PLAN.md del repo. Lo más inmediato es facilitar la instalación del MCP, que hoy pide clonar el repo, y que la actualización de una épica proponga solo los cambios. Después, identidad real y permisos por equipo con Microsoft 365. El chat en el sitio queda como opción si el equipo lo pide, con una key de LLM de la organización. Dos pasos de la versión anterior, Jira en producción y varias épicas, quedaron resueltos con el MCP.</a:t>
             </a:r>
             <a:endParaRPr lang="en-US" dirty="0"/>
           </a:p>
@@ -1042,7 +1042,7 @@
           <a:p>
             <a:r>
               <a:rPr lang="en-US" dirty="0"/>
-              <a:t>La pieza central es el glosario: no lo escribe nadie de cero, lo propone un LLM a partir de Jira y una persona lo aprueba. De ahí salen dos cosas: una wiki para buscar y un chat para preguntar en lenguaje natural. La regla de oro del chat: nunca inventa, siempre cita la tarjeta de donde sale el dato.</a:t>
+              <a:t>La pieza central es el glosario, ahora uno por épica. No lo escribe nadie de cero: lo propone la IA a partir de Jira y una persona lo aprueba. Quién lo arma: cada mantenedor, con su propio Claude y el MCP local wiki-viva. Quién lo usa: todo el equipo, desde la wiki. Después del challenge sacamos el chat del sitio: las preguntas en lenguaje natural se le hacen al Claude de cada uno.</a:t>
             </a:r>
             <a:endParaRPr lang="en-US" dirty="0"/>
           </a:p>
@@ -1130,7 +1130,7 @@
           <a:p>
             <a:r>
               <a:rPr lang="en-US" dirty="0"/>
-              <a:t>El ciclo completo. Los pasos 1 a 3 se hacen una vez por épica, en local. Los pasos 4 y 5 son el uso diario: la gente consulta y, cuando algo falta, lo agrega desde el mismo chat, así el glosario crece con el uso. Por eso lo llamamos wiki viva.</a:t>
+              <a:t>El ciclo completo, guiado por el prompt armar_glosario del MCP. 1: la épica queda tomada a tu nombre en epics.json, así dos personas no trabajan la misma. 2 y 3: Claude lee las tarjetas por páginas y propone los términos, solo con lo que dicen las tarjetas. 4: la revisión humana pasa en la misma conversación, y nada se publica sin tu OK. 5: la wiki lo toma en alrededor de un minuto.</a:t>
             </a:r>
             <a:endParaRPr lang="en-US" dirty="0"/>
           </a:p>
@@ -1218,7 +1218,7 @@
           <a:p>
             <a:r>
               <a:rPr lang="en-US" dirty="0"/>
-              <a:t>Tres bloques. Arriba, la extracción: corre en local una vez por épica y termina en una revisión humana. A la derecha, el repo privado con el glosario: es la fuente de verdad. Abajo, la app en Vercel: la wiki y el chat leen el glosario desde GitHub con caché; el chat además tiene el snapshot de la épica, cacheado 10 minutos. El LLM se usa vía OpenRouter, siempre a través de una única función, getModel().</a:t>
+              <a:t>Tres bloques. A la izquierda, el mantenedor: Claude Code o Desktop con el MCP wiki-viva, que lee Jira desde su PC con su VPN y su token. En el medio, el repo privado: un glosario por épica y epics.json con el estado de cada una; los commits quedan a nombre de quien publica. A la derecha, la wiki en Vercel: solo lee el repo por la API de GitHub, con caché de un minuto. Así se resolvió el problema de Jira con VPN en producción: el servidor ya no necesita Jira ni una key de LLM.</a:t>
             </a:r>
             <a:endParaRPr lang="en-US" dirty="0"/>
           </a:p>
@@ -1306,7 +1306,7 @@
           <a:p>
             <a:r>
               <a:rPr lang="en-US" dirty="0"/>
-              <a:t>Stack simple a propósito: era un MVP de un día. Las decisiones importantes: el LLM nunca escribe directo en el glosario, una persona revisa; no hay base de datos; toda fuente de datos implementa la misma interfaz, así que sumar Confluence o Notion es un conector nuevo; y el modelo se elige por variable de entorno, con una lista de respaldo por si uno está saturado.</a:t>
+              <a:t>Stack simple a propósito. Las decisiones importantes: la IA nunca escribe sola en el glosario, una persona aprueba en la misma conversación; no hay IA en el servidor, así que no dependemos de modelos gratis ni de una key de LLM; Jira se lee solo desde local, donde la VPN ya está; no hay base de datos; y toda fuente implementa la misma interfaz, así que sumar Confluence o Notion es un conector nuevo.</a:t>
             </a:r>
             <a:endParaRPr lang="en-US" dirty="0"/>
           </a:p>
@@ -1938,7 +1938,7 @@
       </p:grpSpPr>
       <p:pic>
         <p:nvPicPr>
-          <p:cNvPr id="2" name="Slide 1" descr="Flock · IA Day · Challenge Wiki viva de terminología Un glosario del negocio extraído de Jira con IA, revisado por personas, con una wiki y un chat que responden citando las tarjetas de origen.">    </p:cNvPr>
+          <p:cNvPr id="2" name="Slide 1" descr="Flock · IA Day · Challenge. Wiki viva de terminología. Un glosario del negocio por épica, extraído de Jira con IA, revisado por personas y publicado en una wiki que cita las tarjetas de origen.">    </p:cNvPr>
           <p:cNvPicPr>
             <a:picLocks noChangeAspect="1"/>
           </p:cNvPicPr>
@@ -2085,7 +2085,7 @@
       </p:grpSpPr>
       <p:pic>
         <p:nvPicPr>
-          <p:cNvPr id="2" name="Slide 12" descr="Flock | Próximos pasos 12 Próximos pasos Jira en producción Publicar el snapshot de la épica en el repo privado, generado con VPN o con el MCP de Atlassian. Mejores respuestas Un modelo más capaz y solo las tarjetas relevantes en el contexto. Login con Microsoft 365 Sin contraseñas compartidas, y queda registrado quién agrega cada término. Varias épicas Extracción incremental y filtro por épica en la wiki. Acceso por equipo Cada persona ve solo las épicas de su equipo, según sus grupos de Microsoft 365.">    </p:cNvPr>
+          <p:cNvPr id="2" name="Slide 12" descr="Flock | Próximos pasos 12. Próximos pasos. Instalación con npx: sumar el MCP sin clonar el repo, con una guía corta para Claude Code y Desktop. Actualización incremental: que Claude proponga solo los cambios de la épica desde la última publicación. Login con Microsoft 365: sin contraseñas compartidas en la wiki. Acceso por equipo: cada persona ve solo las épicas de su equipo, según sus grupos de Microsoft 365. Chat en el sitio, opcional: volver a sumarlo con una key de LLM de la organización, si el equipo lo pide.">    </p:cNvPr>
           <p:cNvPicPr>
             <a:picLocks noChangeAspect="1"/>
           </p:cNvPicPr>
@@ -2232,7 +2232,7 @@
       </p:grpSpPr>
       <p:pic>
         <p:nvPicPr>
-          <p:cNvPr id="2" name="Slide 3" descr="Flock | Qué construimos 03 Un glosario vivo con dos salidas La base Glosario Un LLM lo extrae de una épica de Jira y una persona lo revisa antes de publicarlo. Salida 1 Wiki Buscador de términos con sinónimos, casos especiales y fuentes linkeadas a Jira. Salida 2 Chat Responde solo con el glosario y la épica, citando las tarjetas. Si no sabe, lo dice y ofrece agregar el término.">    </p:cNvPr>
+          <p:cNvPr id="2" name="Slide 3" descr="Flock | Qué construimos 03. Un glosario vivo, por épica. La base, Glosario por épica: uno por cada épica de Jira, en un repo privado; lo propone la IA y lo aprueba una persona. Mantenedores, MCP local: cada mantenedor trabaja con su propio Claude, lee la épica por VPN, propone los términos y publica con su OK. Todo el equipo, Wiki: buscador de términos con sinónimos, casos especiales, fuentes linkeadas a Jira y filtro por épica.">    </p:cNvPr>
           <p:cNvPicPr>
             <a:picLocks noChangeAspect="1"/>
           </p:cNvPicPr>
@@ -2281,7 +2281,7 @@
       </p:grpSpPr>
       <p:pic>
         <p:nvPicPr>
-          <p:cNvPr id="2" name="Slide 4" descr="Flock | Qué construimos 04 Cómo funciona, de punta a punta 1 Conectar Jira: épica, historias, subtareas y comentarios. 2 Extraer Un LLM arma el borrador del glosario, por lotes. 3 Revisar Una persona depura, corrige y aprueba. 4 Consultar Wiki y chat con citas a las tarjetas. 5 Completar Lo que falta se agrega desde el chat.">    </p:cNvPr>
+          <p:cNvPr id="2" name="Slide 4" descr="Flock | Qué construimos 04. Cómo funciona, de punta a punta. 1 Tomar: la épica queda a tu nombre, nadie más la trabaja en paralelo. 2 Leer: Claude trae por el MCP la épica, historias, subtareas y comentarios. 3 Proponer: Claude arma el glosario con reglas estrictas, solo lo que dicen las tarjetas. 4 Revisar: lo revisan juntos en la conversación y se publica con tu OK. 5 Consultar: la wiki lo muestra en un minuto, con filtro por épica.">    </p:cNvPr>
           <p:cNvPicPr>
             <a:picLocks noChangeAspect="1"/>
           </p:cNvPicPr>
@@ -2330,7 +2330,7 @@
       </p:grpSpPr>
       <p:pic>
         <p:nvPicPr>
-          <p:cNvPr id="2" name="Slide 5" descr="Flock | Cómo está hecho 05 Arquitectura Extracción una vez por épica en local · glosario en un repo privado leído vía API de GitHub con caché · chat con el glosario y la épica en contexto · lo que falta vuelve al glosario con un commit.">    </p:cNvPr>
+          <p:cNvPr id="2" name="Slide 5" descr="Flock | Cómo está hecho 05. Arquitectura. Jira alimenta al MCP wiki-viva, que corre en la PC del mantenedor junto con Claude Code o Desktop; el MCP commitea en el repo privado (glossaries por épica y epics.json); la wiki en Vercel lee el repo por la API de GitHub con caché de un minuto. El MCP corre en la PC de cada mantenedor, con su VPN y sus tokens · los glosarios viven en un repo privado · el sitio solo lee, sin IA ni Jira en el servidor.">    </p:cNvPr>
           <p:cNvPicPr>
             <a:picLocks noChangeAspect="1"/>
           </p:cNvPicPr>
@@ -2379,7 +2379,7 @@
       </p:grpSpPr>
       <p:pic>
         <p:nvPicPr>
-          <p:cNvPr id="2" name="Slide 6" descr="Flock | Cómo está hecho 06 Stack y decisiones de diseño Stack Next.js 16 + TypeScript + Tailwind Vercel AI SDK: streaming y salida estructurada OpenRouter, con modelos de respaldo Jira Cloud REST API Vercel: deploy automático en cada push Decisiones Humano en el loop: el LLM propone, una persona aprueba Sin base de datos: Jira cacheado y glosario en GitHub Conectores enchufables: sumar una fuente es un archivo Un solo punto de acceso al LLM: cambiar de modelo es una variable">    </p:cNvPr>
+          <p:cNvPr id="2" name="Slide 6" descr="Flock | Cómo está hecho 06. Stack y decisiones de diseño. Stack: Next.js 16 + TypeScript + Tailwind; MCP TypeScript SDK, servidor local por stdio; Claude Code o Desktop de cada mantenedor; Jira Cloud REST API; Vercel, deploy automático en cada push. Decisiones: humano en el loop, Claude propone y la persona aprueba en la misma conversación; sin IA en el servidor, no hace falta key de LLM; Jira solo desde local, la VPN deja de ser un problema; sin base de datos, glosarios y estado en un repo privado; conectores enchufables, sumar una fuente es un archivo.">    </p:cNvPr>
           <p:cNvPicPr>
             <a:picLocks noChangeAspect="1"/>
           </p:cNvPicPr>

</xml_diff>